<commit_message>
Karnataka: roll of 9 October 2026; Jharkhand final roll moved to 30 November; Telangana's exact roll before
Karnataka's pages, report and deck move from the roll of 25 September to the
CEO's press note of 9 October (45,161,393 electors, by district and sex),
with its notices and forms tables added to raw and the downloads. The state
row is matched to the press; the district rows add exactly to it.
Jharkhand's final roll date follows the CEO as quoted by Town Post (30
November). Telangana's roll before the revision is 3,38,26,448 (Telangana
Today, from the CEO), replacing the rounded 3.38 crore. The figures-as-of
line now reads moved dates, and the place name above each heading uses the
normal type in non-Latin scripts.

Co-Authored-By: Claude Opus 5.5 <noreply@anthropic.com>
Claude-Session: https://claude.ai/code/session_01FWx24PCx3Jw4SUDQC6oU7o
</commit_message>
<xml_diff>
--- a/reports/karnataka-sir-2026-deck.pptx
+++ b/reports/karnataka-sir-2026-deck.pptx
@@ -1936,7 +1936,7 @@
               <c:strCache>
                 <c:ptCount val="1"/>
                 <c:pt idx="0">
-                  <c:v>On 25 September</c:v>
+                  <c:v>On 9 October</c:v>
                 </c:pt>
               </c:strCache>
             </c:strRef>
@@ -2025,40 +2025,40 @@
                 <c:formatCode>General</c:formatCode>
                 <c:ptCount val="12"/>
                 <c:pt idx="0">
-                  <c:v>49.33</c:v>
+                  <c:v>49.22</c:v>
                 </c:pt>
                 <c:pt idx="1">
-                  <c:v>45.47</c:v>
+                  <c:v>44.54</c:v>
                 </c:pt>
                 <c:pt idx="2">
-                  <c:v>45.09</c:v>
+                  <c:v>44.49</c:v>
                 </c:pt>
                 <c:pt idx="3">
-                  <c:v>42.71</c:v>
+                  <c:v>42.37</c:v>
                 </c:pt>
                 <c:pt idx="4">
-                  <c:v>21.8</c:v>
+                  <c:v>21.18</c:v>
                 </c:pt>
                 <c:pt idx="5">
-                  <c:v>19.72</c:v>
+                  <c:v>19.16</c:v>
                 </c:pt>
                 <c:pt idx="6">
-                  <c:v>17.91</c:v>
+                  <c:v>17.16</c:v>
                 </c:pt>
                 <c:pt idx="7">
-                  <c:v>17.5</c:v>
+                  <c:v>17.15</c:v>
                 </c:pt>
                 <c:pt idx="8">
-                  <c:v>17.89</c:v>
+                  <c:v>16.29</c:v>
                 </c:pt>
                 <c:pt idx="9">
-                  <c:v>16.32</c:v>
+                  <c:v>15.68</c:v>
                 </c:pt>
                 <c:pt idx="10">
-                  <c:v>16.22</c:v>
+                  <c:v>15.52</c:v>
                 </c:pt>
                 <c:pt idx="11">
-                  <c:v>14.61</c:v>
+                  <c:v>14.09</c:v>
                 </c:pt>
               </c:numCache>
             </c:numRef>
@@ -3149,7 +3149,7 @@
           <a:p>
             <a:r>
               <a:rPr lang="en-US" dirty="0"/>
-              <a:t>The draft roll is the roll published after the house-to-house check. Per 100 electors is the number left off for every 100 people on the roll of 16 June, which lets districts of different size be compared. Electors kept on the draft can still be sent a notice to appear at a hearing, and those hearings were under way on 25 September.</a:t>
+              <a:t>The draft roll is the roll published after the house-to-house check. Per 100 electors is the number left off for every 100 people on the roll of 16 June, which lets districts of different size be compared. Electors kept on the draft can still be sent a notice to appear at a hearing, and those hearings were under way on 9 October.</a:t>
             </a:r>
             <a:endParaRPr lang="en-US" dirty="0"/>
           </a:p>
@@ -4538,7 +4538,7 @@
                 <a:ea typeface="Cambria" pitchFamily="34" charset="-122"/>
                 <a:cs typeface="Cambria" pitchFamily="34" charset="-120"/>
               </a:rPr>
-              <a:t>1.9%</a:t>
+              <a:t>4.9%</a:t>
             </a:r>
             <a:endParaRPr lang="en-US" sz="3000" dirty="0"/>
           </a:p>
@@ -4579,7 +4579,7 @@
                 <a:ea typeface="Calibri" pitchFamily="34" charset="-122"/>
                 <a:cs typeface="Calibri" pitchFamily="34" charset="-120"/>
               </a:rPr>
-              <a:t>of the names removed back by 25 September</a:t>
+              <a:t>of the names removed back by 9 October</a:t>
             </a:r>
             <a:endParaRPr lang="en-US" sz="1250" dirty="0"/>
           </a:p>
@@ -6464,7 +6464,7 @@
                 <a:ea typeface="Calibri" pitchFamily="34" charset="-122"/>
                 <a:cs typeface="Calibri" pitchFamily="34" charset="-120"/>
               </a:rPr>
-              <a:t>How many names were left off the draft in each of the 34 election districts, on what recorded reason, and how the roll stood on 25 September.</a:t>
+              <a:t>How many names were left off the draft in each of the 34 election districts, on what recorded reason, and how the roll stood on 9 October.</a:t>
             </a:r>
             <a:endParaRPr lang="en-US" sz="1500" dirty="0"/>
           </a:p>
@@ -8737,7 +8737,7 @@
                 <a:ea typeface="Calibri" pitchFamily="34" charset="-122"/>
                 <a:cs typeface="Calibri" pitchFamily="34" charset="-120"/>
               </a:rPr>
-              <a:t>The roll of 25 September 2026, by district and sex, is from the press note of that date. The final roll is due on 27 October.</a:t>
+              <a:t>The roll of 9 October 2026, by district and sex, is from the press note of that date. The final roll is due on 27 October.</a:t>
             </a:r>
             <a:endParaRPr lang="en-US" sz="1600" dirty="0"/>
           </a:p>
@@ -11954,7 +11954,7 @@
                 <a:ea typeface="Calibri" pitchFamily="34" charset="-122"/>
                 <a:cs typeface="Calibri" pitchFamily="34" charset="-120"/>
               </a:rPr>
-              <a:t>By 25 September the roll had risen by 2,08,105 since the draft, 1.9% of the names removed. In Bengaluru it rose by 2,340.</a:t>
+              <a:t>By 9 October the roll had risen by 5,25,418 since the draft, 4.9% of the names removed. In Bengaluru it rose by 49,951.</a:t>
             </a:r>
             <a:endParaRPr lang="en-US" sz="1700" dirty="0"/>
           </a:p>
@@ -12142,7 +12142,7 @@
                 <a:ea typeface="Calibri" pitchFamily="34" charset="-122"/>
                 <a:cs typeface="Calibri" pitchFamily="34" charset="-120"/>
               </a:rPr>
-              <a:t>The state's roll, step by step, to 25 September 2026, while notices were still being heard</a:t>
+              <a:t>The state's roll, step by step, to 9 October 2026, while notices were still being heard</a:t>
             </a:r>
             <a:endParaRPr lang="en-US" sz="1400" dirty="0"/>
           </a:p>
@@ -13748,8 +13748,8 @@
         </p:nvSpPr>
         <p:spPr>
           <a:xfrm>
-            <a:off x="9362537" y="4070492"/>
-            <a:ext cx="862899" cy="31866"/>
+            <a:off x="9362537" y="4021904"/>
+            <a:ext cx="862899" cy="80453"/>
           </a:xfrm>
           <a:prstGeom prst="rect">
             <a:avLst/>
@@ -13768,7 +13768,7 @@
         </p:nvSpPr>
         <p:spPr>
           <a:xfrm>
-            <a:off x="9177630" y="3796172"/>
+            <a:off x="9177630" y="3747584"/>
             <a:ext cx="1232713" cy="256032"/>
           </a:xfrm>
           <a:prstGeom prst="rect">
@@ -13795,7 +13795,7 @@
                 <a:ea typeface="Calibri" pitchFamily="34" charset="-122"/>
                 <a:cs typeface="Calibri" pitchFamily="34" charset="-120"/>
               </a:rPr>
-              <a:t>+2,08,105</a:t>
+              <a:t>+5,25,418</a:t>
             </a:r>
             <a:endParaRPr lang="en-US" sz="1000" dirty="0"/>
           </a:p>
@@ -13850,8 +13850,8 @@
         </p:nvSpPr>
         <p:spPr>
           <a:xfrm>
-            <a:off x="10595249" y="4070492"/>
-            <a:ext cx="862899" cy="1507348"/>
+            <a:off x="10595249" y="4021904"/>
+            <a:ext cx="862899" cy="1555936"/>
           </a:xfrm>
           <a:prstGeom prst="rect">
             <a:avLst/>
@@ -13870,7 +13870,7 @@
         </p:nvSpPr>
         <p:spPr>
           <a:xfrm>
-            <a:off x="10410342" y="3796172"/>
+            <a:off x="10410342" y="3747584"/>
             <a:ext cx="1232713" cy="256032"/>
           </a:xfrm>
           <a:prstGeom prst="rect">
@@ -13897,7 +13897,7 @@
                 <a:ea typeface="Calibri" pitchFamily="34" charset="-122"/>
                 <a:cs typeface="Calibri" pitchFamily="34" charset="-120"/>
               </a:rPr>
-              <a:t>4,48,44,080</a:t>
+              <a:t>4,51,61,393</a:t>
             </a:r>
             <a:endParaRPr lang="en-US" sz="1000" dirty="0"/>
           </a:p>
@@ -13938,7 +13938,7 @@
                 <a:ea typeface="Calibri" pitchFamily="34" charset="-122"/>
                 <a:cs typeface="Calibri" pitchFamily="34" charset="-120"/>
               </a:rPr>
-              <a:t>Roll of 25 September</a:t>
+              <a:t>Roll of 9 October</a:t>
             </a:r>
             <a:endParaRPr lang="en-US" sz="1000" dirty="0"/>
           </a:p>
@@ -17735,7 +17735,7 @@
                 <a:ea typeface="Calibri" pitchFamily="34" charset="-122"/>
                 <a:cs typeface="Calibri" pitchFamily="34" charset="-120"/>
               </a:rPr>
-              <a:t>By 25 September Bengaluru's roll had risen by 2,340 since the draft, against 46.9 lakh names removed. In the rest of the state the rise came to 3.4% of the names removed.</a:t>
+              <a:t>By 9 October Bengaluru's roll had risen by 49,951 since the draft, against 46.9 lakh names removed. In the rest of the state the rise came to 7.8% of the names removed.</a:t>
             </a:r>
             <a:endParaRPr lang="en-US" sz="1600" dirty="0"/>
           </a:p>
@@ -18965,7 +18965,7 @@
                 <a:ea typeface="Calibri" pitchFamily="34" charset="-122"/>
                 <a:cs typeface="Calibri" pitchFamily="34" charset="-120"/>
               </a:rPr>
-              <a:t>women's share of the roll of 25 September</a:t>
+              <a:t>women's share of the roll of 9 October</a:t>
             </a:r>
             <a:endParaRPr lang="en-US" sz="1200" dirty="0"/>
           </a:p>
@@ -19114,7 +19114,7 @@
                 <a:ea typeface="Cambria" pitchFamily="34" charset="-122"/>
                 <a:cs typeface="Cambria" pitchFamily="34" charset="-120"/>
               </a:rPr>
-              <a:t>By 25 September only 1.9% of the names removed had come back, and 0.05% in Bengaluru</a:t>
+              <a:t>By 9 October only 4.9% of the names removed had come back, and 1.07% in Bengaluru</a:t>
             </a:r>
             <a:endParaRPr lang="en-US" sz="2700" dirty="0"/>
           </a:p>
@@ -19153,7 +19153,7 @@
                 <a:ea typeface="Calibri" pitchFamily="34" charset="-122"/>
                 <a:cs typeface="Calibri" pitchFamily="34" charset="-120"/>
               </a:rPr>
-              <a:t>Removed at the draft and the fall left on 25 September, per 100 electors, the twelve districts with the highest rates</a:t>
+              <a:t>Removed at the draft and the fall left on 9 October, per 100 electors, the twelve districts with the highest rates</a:t>
             </a:r>
             <a:endParaRPr lang="en-US" sz="1400" dirty="0"/>
           </a:p>
@@ -20092,7 +20092,7 @@
                 <a:ea typeface="Calibri" pitchFamily="34" charset="-122"/>
                 <a:cs typeface="Calibri" pitchFamily="34" charset="-120"/>
               </a:rPr>
-              <a:t>The roll rose by 2,08,105 after the draft, against 1.08 crore names removed.</a:t>
+              <a:t>The roll rose by 5,25,418 after the draft, against 1.08 crore names removed.</a:t>
             </a:r>
             <a:endParaRPr lang="en-US" sz="1400" dirty="0"/>
           </a:p>

</xml_diff>

<commit_message>
Karnataka final roll of 27 October, first reading (second reading in progress)
Co-Authored-By: Claude Opus 5.5 <noreply@anthropic.com>
Claude-Session: https://claude.ai/code/session_012JjD5mhtvLxzAXoZHMZYE5
</commit_message>
<xml_diff>
--- a/reports/karnataka-sir-2026-deck.pptx
+++ b/reports/karnataka-sir-2026-deck.pptx
@@ -2621,7 +2621,7 @@
           <a:p>
             <a:r>
               <a:rPr lang="en-US" dirty="0"/>
-              <a:t>The Special Intensive Revision (SIR) is the Election Commission's house-to-house recheck of the electoral roll, the list of people entitled to vote. Every figure is computed from the Chief Electoral Officer's district tables. Nothing has been published by assembly constituency, so there is no comparison with election margins. The final roll is due on 27 October 2026.</a:t>
+              <a:t>The Special Intensive Revision (SIR) is the Election Commission's house-to-house recheck of the electoral roll, the list of people entitled to vote. Every figure is computed from the Chief Electoral Officer's district tables. Nothing has been published by assembly constituency, so there is no comparison with election margins. The final roll of 27 October 2026 was reported for the state only.</a:t>
             </a:r>
             <a:endParaRPr lang="en-US" dirty="0"/>
           </a:p>
@@ -3149,7 +3149,7 @@
           <a:p>
             <a:r>
               <a:rPr lang="en-US" dirty="0"/>
-              <a:t>The draft roll is the roll published after the house-to-house check. Per 100 electors is the number left off for every 100 people on the roll of 16 June, which lets districts of different size be compared. Electors kept on the draft can still be sent a notice to appear at a hearing, and those hearings were under way on 9 October.</a:t>
+              <a:t>The draft roll is the roll published after the house-to-house check. Per 100 electors is the number left off for every 100 people on the roll of 16 June, which lets districts of different size be compared. Electors kept on the draft can still be sent a notice to appear at a hearing, and those hearings were to be decided by 22 October, before the final roll of 27 October.</a:t>
             </a:r>
             <a:endParaRPr lang="en-US" dirty="0"/>
           </a:p>
@@ -3237,7 +3237,7 @@
           <a:p>
             <a:r>
               <a:rPr lang="en-US" dirty="0"/>
-              <a:t>The bars start above zero so that the changes can be seen. The final roll is due on 27 October 2026. A reason on the list is what the officer wrote down, and nobody checked it.</a:t>
+              <a:t>The bars start above zero so that the changes can be seen. No count of names added or deleted after the draft was published, so the last step is the net change. A reason on the list is what the officer wrote down, and nobody checked it.</a:t>
             </a:r>
             <a:endParaRPr lang="en-US" dirty="0"/>
           </a:p>
@@ -4163,7 +4163,7 @@
                 <a:ea typeface="Calibri" pitchFamily="34" charset="-122"/>
                 <a:cs typeface="Calibri" pitchFamily="34" charset="-120"/>
               </a:rPr>
-              <a:t>District by district, on what recorded reason, and how the roll stood while notices were still being heard</a:t>
+              <a:t>District by district, on what recorded reason, and the final roll of 27 October 2026</a:t>
             </a:r>
             <a:endParaRPr lang="en-US" sz="1700" dirty="0"/>
           </a:p>
@@ -4538,7 +4538,7 @@
                 <a:ea typeface="Cambria" pitchFamily="34" charset="-122"/>
                 <a:cs typeface="Cambria" pitchFamily="34" charset="-120"/>
               </a:rPr>
-              <a:t>4.9%</a:t>
+              <a:t>8.0%</a:t>
             </a:r>
             <a:endParaRPr lang="en-US" sz="3000" dirty="0"/>
           </a:p>
@@ -4579,7 +4579,7 @@
                 <a:ea typeface="Calibri" pitchFamily="34" charset="-122"/>
                 <a:cs typeface="Calibri" pitchFamily="34" charset="-120"/>
               </a:rPr>
-              <a:t>of the names left off back by 9 October</a:t>
+              <a:t>of the names left off back by the final roll</a:t>
             </a:r>
             <a:endParaRPr lang="en-US" sz="1250" dirty="0"/>
           </a:p>
@@ -6676,7 +6676,7 @@
                 <a:ea typeface="Cambria" pitchFamily="34" charset="-122"/>
                 <a:cs typeface="Cambria" pitchFamily="34" charset="-120"/>
               </a:rPr>
-              <a:t>Publish the revision by constituency and by sex before the final roll</a:t>
+              <a:t>Publish the revision by constituency and by sex</a:t>
             </a:r>
             <a:endParaRPr lang="en-US" sz="2700" dirty="0"/>
           </a:p>
@@ -7688,7 +7688,7 @@
                 <a:ea typeface="Calibri" pitchFamily="34" charset="-122"/>
                 <a:cs typeface="Calibri" pitchFamily="34" charset="-120"/>
               </a:rPr>
-              <a:t>Publish with the final roll how many of those added had been left off the draft.</a:t>
+              <a:t>Publish how many names were added and deleted after the draft, and how many of those added had been left off it.</a:t>
             </a:r>
             <a:endParaRPr lang="en-US" sz="1700" dirty="0"/>
           </a:p>
@@ -8737,7 +8737,7 @@
                 <a:ea typeface="Calibri" pitchFamily="34" charset="-122"/>
                 <a:cs typeface="Calibri" pitchFamily="34" charset="-120"/>
               </a:rPr>
-              <a:t>The roll of 9 October 2026, by district and sex, is from the press note of that date. The final roll is due on 27 October.</a:t>
+              <a:t>The roll of 9 October 2026, by district and sex, is from the press note of that date. The final roll of 27 October 2026, for the state only, is from The Hindu's and ETV Bharat's reports of the Chief Electoral Officer's figures.</a:t>
             </a:r>
             <a:endParaRPr lang="en-US" sz="1600" dirty="0"/>
           </a:p>
@@ -11954,7 +11954,7 @@
                 <a:ea typeface="Calibri" pitchFamily="34" charset="-122"/>
                 <a:cs typeface="Calibri" pitchFamily="34" charset="-120"/>
               </a:rPr>
-              <a:t>By 9 October the roll had risen by 5,25,418 since the draft, 4.9% of the names left off. In Bengaluru it rose by 49,951.</a:t>
+              <a:t>The final roll of 27 October 2026 has 4,55,00,011 electors, 8,64,036 more than the draft, which is 8.0% of the names left off.</a:t>
             </a:r>
             <a:endParaRPr lang="en-US" sz="1700" dirty="0"/>
           </a:p>
@@ -12142,7 +12142,7 @@
                 <a:ea typeface="Calibri" pitchFamily="34" charset="-122"/>
                 <a:cs typeface="Calibri" pitchFamily="34" charset="-120"/>
               </a:rPr>
-              <a:t>The state's roll, step by step, to 9 October 2026, while notices were still being heard</a:t>
+              <a:t>The state's roll, step by step, to the final roll of 27 October 2026</a:t>
             </a:r>
             <a:endParaRPr lang="en-US" sz="1400" dirty="0"/>
           </a:p>
@@ -13748,8 +13748,8 @@
         </p:nvSpPr>
         <p:spPr>
           <a:xfrm>
-            <a:off x="9362537" y="4021904"/>
-            <a:ext cx="862899" cy="80453"/>
+            <a:off x="9362537" y="3970054"/>
+            <a:ext cx="862899" cy="132303"/>
           </a:xfrm>
           <a:prstGeom prst="rect">
             <a:avLst/>
@@ -13768,7 +13768,7 @@
         </p:nvSpPr>
         <p:spPr>
           <a:xfrm>
-            <a:off x="9177630" y="3747584"/>
+            <a:off x="9177630" y="3695734"/>
             <a:ext cx="1232713" cy="256032"/>
           </a:xfrm>
           <a:prstGeom prst="rect">
@@ -13795,7 +13795,7 @@
                 <a:ea typeface="Calibri" pitchFamily="34" charset="-122"/>
                 <a:cs typeface="Calibri" pitchFamily="34" charset="-120"/>
               </a:rPr>
-              <a:t>+5,25,418</a:t>
+              <a:t>+8,64,036</a:t>
             </a:r>
             <a:endParaRPr lang="en-US" sz="1000" dirty="0"/>
           </a:p>
@@ -13850,8 +13850,8 @@
         </p:nvSpPr>
         <p:spPr>
           <a:xfrm>
-            <a:off x="10595249" y="4021904"/>
-            <a:ext cx="862899" cy="1555936"/>
+            <a:off x="10595249" y="3970054"/>
+            <a:ext cx="862899" cy="1607786"/>
           </a:xfrm>
           <a:prstGeom prst="rect">
             <a:avLst/>
@@ -13870,7 +13870,7 @@
         </p:nvSpPr>
         <p:spPr>
           <a:xfrm>
-            <a:off x="10410342" y="3747584"/>
+            <a:off x="10410342" y="3695734"/>
             <a:ext cx="1232713" cy="256032"/>
           </a:xfrm>
           <a:prstGeom prst="rect">
@@ -13897,7 +13897,7 @@
                 <a:ea typeface="Calibri" pitchFamily="34" charset="-122"/>
                 <a:cs typeface="Calibri" pitchFamily="34" charset="-120"/>
               </a:rPr>
-              <a:t>4,51,61,393</a:t>
+              <a:t>4,55,00,011</a:t>
             </a:r>
             <a:endParaRPr lang="en-US" sz="1000" dirty="0"/>
           </a:p>
@@ -13938,7 +13938,7 @@
                 <a:ea typeface="Calibri" pitchFamily="34" charset="-122"/>
                 <a:cs typeface="Calibri" pitchFamily="34" charset="-120"/>
               </a:rPr>
-              <a:t>Roll of 9 October</a:t>
+              <a:t>Final roll</a:t>
             </a:r>
             <a:endParaRPr lang="en-US" sz="1000" dirty="0"/>
           </a:p>
@@ -18772,7 +18772,7 @@
         <p:spPr>
           <a:xfrm>
             <a:off x="548640" y="1920240"/>
-            <a:ext cx="5432908" cy="1645920"/>
+            <a:ext cx="3545738" cy="1645920"/>
           </a:xfrm>
           <a:prstGeom prst="roundRect">
             <a:avLst>
@@ -18794,7 +18794,7 @@
         <p:spPr>
           <a:xfrm>
             <a:off x="731520" y="2029968"/>
-            <a:ext cx="5067148" cy="790042"/>
+            <a:ext cx="3179978" cy="790042"/>
           </a:xfrm>
           <a:prstGeom prst="rect">
             <a:avLst/>
@@ -18835,7 +18835,7 @@
         <p:spPr>
           <a:xfrm>
             <a:off x="731520" y="2838298"/>
-            <a:ext cx="5067148" cy="636422"/>
+            <a:ext cx="3179978" cy="636422"/>
           </a:xfrm>
           <a:prstGeom prst="rect">
             <a:avLst/>
@@ -18875,8 +18875,8 @@
         </p:nvSpPr>
         <p:spPr>
           <a:xfrm>
-            <a:off x="6210148" y="1920240"/>
-            <a:ext cx="5432908" cy="1645920"/>
+            <a:off x="4322978" y="1920240"/>
+            <a:ext cx="3545738" cy="1645920"/>
           </a:xfrm>
           <a:prstGeom prst="roundRect">
             <a:avLst>
@@ -18897,8 +18897,8 @@
         </p:nvSpPr>
         <p:spPr>
           <a:xfrm>
-            <a:off x="6393028" y="2029968"/>
-            <a:ext cx="5067148" cy="790042"/>
+            <a:off x="4505858" y="2029968"/>
+            <a:ext cx="3179978" cy="790042"/>
           </a:xfrm>
           <a:prstGeom prst="rect">
             <a:avLst/>
@@ -18938,8 +18938,8 @@
         </p:nvSpPr>
         <p:spPr>
           <a:xfrm>
-            <a:off x="6393028" y="2838298"/>
-            <a:ext cx="5067148" cy="636422"/>
+            <a:off x="4505858" y="2838298"/>
+            <a:ext cx="3179978" cy="636422"/>
           </a:xfrm>
           <a:prstGeom prst="rect">
             <a:avLst/>
@@ -18973,7 +18973,111 @@
       </p:sp>
       <p:sp>
         <p:nvSpPr>
-          <p:cNvPr id="53" name="Text 51"/>
+          <p:cNvPr id="53" name="Shape 51"/>
+          <p:cNvSpPr/>
+          <p:nvPr/>
+        </p:nvSpPr>
+        <p:spPr>
+          <a:xfrm>
+            <a:off x="8097317" y="1920240"/>
+            <a:ext cx="3545738" cy="1645920"/>
+          </a:xfrm>
+          <a:prstGeom prst="roundRect">
+            <a:avLst>
+              <a:gd name="adj" fmla="val 4444"/>
+            </a:avLst>
+          </a:prstGeom>
+          <a:solidFill>
+            <a:srgbClr val="F4F6F7"/>
+          </a:solidFill>
+          <a:ln/>
+        </p:spPr>
+      </p:sp>
+      <p:sp>
+        <p:nvSpPr>
+          <p:cNvPr id="54" name="Text 52"/>
+          <p:cNvSpPr txBox="1"/>
+          <p:nvPr/>
+        </p:nvSpPr>
+        <p:spPr>
+          <a:xfrm>
+            <a:off x="8280197" y="2029968"/>
+            <a:ext cx="3179978" cy="790042"/>
+          </a:xfrm>
+          <a:prstGeom prst="rect">
+            <a:avLst/>
+          </a:prstGeom>
+          <a:noFill/>
+          <a:ln/>
+        </p:spPr>
+        <p:txBody>
+          <a:bodyPr wrap="square" lIns="0" tIns="0" rIns="0" bIns="0" rtlCol="0" anchor="b">
+            <a:normAutofit/>
+          </a:bodyPr>
+          <a:lstStyle/>
+          <a:p>
+            <a:pPr indent="0" marL="0">
+              <a:buNone/>
+            </a:pPr>
+            <a:r>
+              <a:rPr lang="en-US" sz="2800" b="1" dirty="0">
+                <a:solidFill>
+                  <a:srgbClr val="1E6B52"/>
+                </a:solidFill>
+                <a:latin typeface="Cambria" pitchFamily="34" charset="0"/>
+                <a:ea typeface="Cambria" pitchFamily="34" charset="-122"/>
+                <a:cs typeface="Cambria" pitchFamily="34" charset="-120"/>
+              </a:rPr>
+              <a:t>50.4%</a:t>
+            </a:r>
+            <a:endParaRPr lang="en-US" sz="2800" dirty="0"/>
+          </a:p>
+        </p:txBody>
+      </p:sp>
+      <p:sp>
+        <p:nvSpPr>
+          <p:cNvPr id="55" name="Text 53"/>
+          <p:cNvSpPr txBox="1"/>
+          <p:nvPr/>
+        </p:nvSpPr>
+        <p:spPr>
+          <a:xfrm>
+            <a:off x="8280197" y="2838298"/>
+            <a:ext cx="3179978" cy="636422"/>
+          </a:xfrm>
+          <a:prstGeom prst="rect">
+            <a:avLst/>
+          </a:prstGeom>
+          <a:noFill/>
+          <a:ln/>
+        </p:spPr>
+        <p:txBody>
+          <a:bodyPr wrap="square" lIns="0" tIns="0" rIns="0" bIns="0" rtlCol="0" anchor="t">
+            <a:normAutofit/>
+          </a:bodyPr>
+          <a:lstStyle/>
+          <a:p>
+            <a:pPr indent="0" marL="0">
+              <a:buNone/>
+            </a:pPr>
+            <a:r>
+              <a:rPr lang="en-US" sz="1200" dirty="0">
+                <a:solidFill>
+                  <a:srgbClr val="4D5B69"/>
+                </a:solidFill>
+                <a:latin typeface="Calibri" pitchFamily="34" charset="0"/>
+                <a:ea typeface="Calibri" pitchFamily="34" charset="-122"/>
+                <a:cs typeface="Calibri" pitchFamily="34" charset="-120"/>
+              </a:rPr>
+              <a:t>women's share of the final roll</a:t>
+            </a:r>
+            <a:endParaRPr lang="en-US" sz="1200" dirty="0"/>
+          </a:p>
+        </p:txBody>
+      </p:sp>
+      <p:sp>
+        <p:nvSpPr>
+          <p:cNvPr id="56" name="Text 54"/>
           <p:cNvSpPr txBox="1"/>
           <p:nvPr/>
         </p:nvSpPr>
@@ -19009,7 +19113,7 @@
                 <a:ea typeface="Calibri" pitchFamily="34" charset="-122"/>
                 <a:cs typeface="Calibri" pitchFamily="34" charset="-120"/>
               </a:rPr>
-              <a:t>The names left off are not split by sex. These two figures cannot show whether women were left off more often than men.</a:t>
+              <a:t>The names left off are not split by sex. These figures cannot show whether women were left off more often than men.</a:t>
             </a:r>
             <a:endParaRPr lang="en-US" sz="1600" dirty="0"/>
           </a:p>
@@ -20134,7 +20238,7 @@
                 <a:ea typeface="Calibri" pitchFamily="34" charset="-122"/>
                 <a:cs typeface="Calibri" pitchFamily="34" charset="-120"/>
               </a:rPr>
-              <a:t>The final roll is due on 27 October 2026 and may change this.</a:t>
+              <a:t>By the final roll of 27 October the state's roll was 8,64,036 above the draft. No district figures were given for it.</a:t>
             </a:r>
             <a:endParaRPr lang="en-US" sz="1400" dirty="0"/>
           </a:p>

</xml_diff>

<commit_message>
Karnataka final roll of 27 October 2026 (#222)
- **Roll size.** The final roll has 4,55,00,011 electors (The Hindu),
against 5,54,32,314 before the revision. That is a fall in the roll of
99,32,303, and 8,64,036 more names than the draft.
- **By sex.** 2,25,40,493 men, 2,29,12,355 women and 2,841 third gender,
attributed to the CEO's office (ETV Bharat and PTI).
- **Unexplained gap.** The sexes add up to 44,322 less than the total,
and the page says so. The flags are press and net only.
- **Pages rebuilt.** Karnataka's pages, the front card, the panels (23
states), process.json, the alert form, the report and deck, and What's
New.

A second reader checked every figure and recomputed every derived one.

---
_Generated by [Claude
Code](https://claude.ai/code/session_012JjD5mhtvLxzAXoZHMZYE5)_

---------

Co-authored-by: Claude <noreply@anthropic.com>
</commit_message>
<xml_diff>
--- a/reports/karnataka-sir-2026-deck.pptx
+++ b/reports/karnataka-sir-2026-deck.pptx
@@ -2621,7 +2621,7 @@
           <a:p>
             <a:r>
               <a:rPr lang="en-US" dirty="0"/>
-              <a:t>The Special Intensive Revision (SIR) is the Election Commission's house-to-house recheck of the electoral roll, the list of people entitled to vote. Every figure is computed from the Chief Electoral Officer's district tables. Nothing has been published by assembly constituency, so there is no comparison with election margins. The final roll is due on 27 October 2026.</a:t>
+              <a:t>The Special Intensive Revision (SIR) is the Election Commission's house-to-house recheck of the electoral roll, the list of people entitled to vote. Every figure is computed from the Chief Electoral Officer's district tables. Nothing has been published by assembly constituency, so there is no comparison with election margins. The final roll of 27 October 2026 was reported for the state only.</a:t>
             </a:r>
             <a:endParaRPr lang="en-US" dirty="0"/>
           </a:p>
@@ -3149,7 +3149,7 @@
           <a:p>
             <a:r>
               <a:rPr lang="en-US" dirty="0"/>
-              <a:t>The draft roll is the roll published after the house-to-house check. Per 100 electors is the number left off for every 100 people on the roll of 16 June, which lets districts of different size be compared. Electors kept on the draft can still be sent a notice to appear at a hearing, and those hearings were under way on 9 October.</a:t>
+              <a:t>The draft roll is the roll published after the house-to-house check. Per 100 electors is the number left off for every 100 people on the roll of 16 June, which lets districts of different size be compared. Electors kept on the draft can still be sent a notice to appear at a hearing, and those hearings were to be decided by 22 October, before the final roll of 27 October.</a:t>
             </a:r>
             <a:endParaRPr lang="en-US" dirty="0"/>
           </a:p>
@@ -3237,7 +3237,7 @@
           <a:p>
             <a:r>
               <a:rPr lang="en-US" dirty="0"/>
-              <a:t>The bars start above zero so that the changes can be seen. The final roll is due on 27 October 2026. A reason on the list is what the officer wrote down, and nobody checked it.</a:t>
+              <a:t>The bars start above zero so that the changes can be seen. No count of names added or deleted after the draft was published, so the last step is the net change. A reason on the list is what the officer wrote down, and nobody checked it.</a:t>
             </a:r>
             <a:endParaRPr lang="en-US" dirty="0"/>
           </a:p>
@@ -4163,7 +4163,7 @@
                 <a:ea typeface="Calibri" pitchFamily="34" charset="-122"/>
                 <a:cs typeface="Calibri" pitchFamily="34" charset="-120"/>
               </a:rPr>
-              <a:t>District by district, on what recorded reason, and how the roll stood while notices were still being heard</a:t>
+              <a:t>District by district, on what recorded reason, and the final roll of 27 October 2026</a:t>
             </a:r>
             <a:endParaRPr lang="en-US" sz="1700" dirty="0"/>
           </a:p>
@@ -4538,7 +4538,7 @@
                 <a:ea typeface="Cambria" pitchFamily="34" charset="-122"/>
                 <a:cs typeface="Cambria" pitchFamily="34" charset="-120"/>
               </a:rPr>
-              <a:t>4.9%</a:t>
+              <a:t>8.0%</a:t>
             </a:r>
             <a:endParaRPr lang="en-US" sz="3000" dirty="0"/>
           </a:p>
@@ -4579,7 +4579,7 @@
                 <a:ea typeface="Calibri" pitchFamily="34" charset="-122"/>
                 <a:cs typeface="Calibri" pitchFamily="34" charset="-120"/>
               </a:rPr>
-              <a:t>of the names left off back by 9 October</a:t>
+              <a:t>of the names left off back by the final roll</a:t>
             </a:r>
             <a:endParaRPr lang="en-US" sz="1250" dirty="0"/>
           </a:p>
@@ -6676,7 +6676,7 @@
                 <a:ea typeface="Cambria" pitchFamily="34" charset="-122"/>
                 <a:cs typeface="Cambria" pitchFamily="34" charset="-120"/>
               </a:rPr>
-              <a:t>Publish the revision by constituency and by sex before the final roll</a:t>
+              <a:t>Publish the revision by constituency and by sex</a:t>
             </a:r>
             <a:endParaRPr lang="en-US" sz="2700" dirty="0"/>
           </a:p>
@@ -7688,7 +7688,7 @@
                 <a:ea typeface="Calibri" pitchFamily="34" charset="-122"/>
                 <a:cs typeface="Calibri" pitchFamily="34" charset="-120"/>
               </a:rPr>
-              <a:t>Publish with the final roll how many of those added had been left off the draft.</a:t>
+              <a:t>Publish how many names were added and deleted after the draft, and how many of those added had been left off it.</a:t>
             </a:r>
             <a:endParaRPr lang="en-US" sz="1700" dirty="0"/>
           </a:p>
@@ -8737,7 +8737,7 @@
                 <a:ea typeface="Calibri" pitchFamily="34" charset="-122"/>
                 <a:cs typeface="Calibri" pitchFamily="34" charset="-120"/>
               </a:rPr>
-              <a:t>The roll of 9 October 2026, by district and sex, is from the press note of that date. The final roll is due on 27 October.</a:t>
+              <a:t>The roll of 9 October 2026, by district and sex, is from the press note of that date. The final roll of 27 October 2026, for the state only, is from The Hindu's and ETV Bharat's reports of the Chief Electoral Officer's figures.</a:t>
             </a:r>
             <a:endParaRPr lang="en-US" sz="1600" dirty="0"/>
           </a:p>
@@ -11954,7 +11954,7 @@
                 <a:ea typeface="Calibri" pitchFamily="34" charset="-122"/>
                 <a:cs typeface="Calibri" pitchFamily="34" charset="-120"/>
               </a:rPr>
-              <a:t>By 9 October the roll had risen by 5,25,418 since the draft, 4.9% of the names left off. In Bengaluru it rose by 49,951.</a:t>
+              <a:t>The final roll of 27 October 2026 has 4,55,00,011 electors, 8,64,036 more than the draft, which is 8.0% of the names left off.</a:t>
             </a:r>
             <a:endParaRPr lang="en-US" sz="1700" dirty="0"/>
           </a:p>
@@ -12142,7 +12142,7 @@
                 <a:ea typeface="Calibri" pitchFamily="34" charset="-122"/>
                 <a:cs typeface="Calibri" pitchFamily="34" charset="-120"/>
               </a:rPr>
-              <a:t>The state's roll, step by step, to 9 October 2026, while notices were still being heard</a:t>
+              <a:t>The state's roll, step by step, to the final roll of 27 October 2026</a:t>
             </a:r>
             <a:endParaRPr lang="en-US" sz="1400" dirty="0"/>
           </a:p>
@@ -13748,8 +13748,8 @@
         </p:nvSpPr>
         <p:spPr>
           <a:xfrm>
-            <a:off x="9362537" y="4021904"/>
-            <a:ext cx="862899" cy="80453"/>
+            <a:off x="9362537" y="3970054"/>
+            <a:ext cx="862899" cy="132303"/>
           </a:xfrm>
           <a:prstGeom prst="rect">
             <a:avLst/>
@@ -13768,7 +13768,7 @@
         </p:nvSpPr>
         <p:spPr>
           <a:xfrm>
-            <a:off x="9177630" y="3747584"/>
+            <a:off x="9177630" y="3695734"/>
             <a:ext cx="1232713" cy="256032"/>
           </a:xfrm>
           <a:prstGeom prst="rect">
@@ -13795,7 +13795,7 @@
                 <a:ea typeface="Calibri" pitchFamily="34" charset="-122"/>
                 <a:cs typeface="Calibri" pitchFamily="34" charset="-120"/>
               </a:rPr>
-              <a:t>+5,25,418</a:t>
+              <a:t>+8,64,036</a:t>
             </a:r>
             <a:endParaRPr lang="en-US" sz="1000" dirty="0"/>
           </a:p>
@@ -13850,8 +13850,8 @@
         </p:nvSpPr>
         <p:spPr>
           <a:xfrm>
-            <a:off x="10595249" y="4021904"/>
-            <a:ext cx="862899" cy="1555936"/>
+            <a:off x="10595249" y="3970054"/>
+            <a:ext cx="862899" cy="1607786"/>
           </a:xfrm>
           <a:prstGeom prst="rect">
             <a:avLst/>
@@ -13870,7 +13870,7 @@
         </p:nvSpPr>
         <p:spPr>
           <a:xfrm>
-            <a:off x="10410342" y="3747584"/>
+            <a:off x="10410342" y="3695734"/>
             <a:ext cx="1232713" cy="256032"/>
           </a:xfrm>
           <a:prstGeom prst="rect">
@@ -13897,7 +13897,7 @@
                 <a:ea typeface="Calibri" pitchFamily="34" charset="-122"/>
                 <a:cs typeface="Calibri" pitchFamily="34" charset="-120"/>
               </a:rPr>
-              <a:t>4,51,61,393</a:t>
+              <a:t>4,55,00,011</a:t>
             </a:r>
             <a:endParaRPr lang="en-US" sz="1000" dirty="0"/>
           </a:p>
@@ -13938,7 +13938,7 @@
                 <a:ea typeface="Calibri" pitchFamily="34" charset="-122"/>
                 <a:cs typeface="Calibri" pitchFamily="34" charset="-120"/>
               </a:rPr>
-              <a:t>Roll of 9 October</a:t>
+              <a:t>Final roll</a:t>
             </a:r>
             <a:endParaRPr lang="en-US" sz="1000" dirty="0"/>
           </a:p>
@@ -18772,7 +18772,7 @@
         <p:spPr>
           <a:xfrm>
             <a:off x="548640" y="1920240"/>
-            <a:ext cx="5432908" cy="1645920"/>
+            <a:ext cx="3545738" cy="1645920"/>
           </a:xfrm>
           <a:prstGeom prst="roundRect">
             <a:avLst>
@@ -18794,7 +18794,7 @@
         <p:spPr>
           <a:xfrm>
             <a:off x="731520" y="2029968"/>
-            <a:ext cx="5067148" cy="790042"/>
+            <a:ext cx="3179978" cy="790042"/>
           </a:xfrm>
           <a:prstGeom prst="rect">
             <a:avLst/>
@@ -18835,7 +18835,7 @@
         <p:spPr>
           <a:xfrm>
             <a:off x="731520" y="2838298"/>
-            <a:ext cx="5067148" cy="636422"/>
+            <a:ext cx="3179978" cy="636422"/>
           </a:xfrm>
           <a:prstGeom prst="rect">
             <a:avLst/>
@@ -18875,8 +18875,8 @@
         </p:nvSpPr>
         <p:spPr>
           <a:xfrm>
-            <a:off x="6210148" y="1920240"/>
-            <a:ext cx="5432908" cy="1645920"/>
+            <a:off x="4322978" y="1920240"/>
+            <a:ext cx="3545738" cy="1645920"/>
           </a:xfrm>
           <a:prstGeom prst="roundRect">
             <a:avLst>
@@ -18897,8 +18897,8 @@
         </p:nvSpPr>
         <p:spPr>
           <a:xfrm>
-            <a:off x="6393028" y="2029968"/>
-            <a:ext cx="5067148" cy="790042"/>
+            <a:off x="4505858" y="2029968"/>
+            <a:ext cx="3179978" cy="790042"/>
           </a:xfrm>
           <a:prstGeom prst="rect">
             <a:avLst/>
@@ -18938,8 +18938,8 @@
         </p:nvSpPr>
         <p:spPr>
           <a:xfrm>
-            <a:off x="6393028" y="2838298"/>
-            <a:ext cx="5067148" cy="636422"/>
+            <a:off x="4505858" y="2838298"/>
+            <a:ext cx="3179978" cy="636422"/>
           </a:xfrm>
           <a:prstGeom prst="rect">
             <a:avLst/>
@@ -18973,7 +18973,111 @@
       </p:sp>
       <p:sp>
         <p:nvSpPr>
-          <p:cNvPr id="53" name="Text 51"/>
+          <p:cNvPr id="53" name="Shape 51"/>
+          <p:cNvSpPr/>
+          <p:nvPr/>
+        </p:nvSpPr>
+        <p:spPr>
+          <a:xfrm>
+            <a:off x="8097317" y="1920240"/>
+            <a:ext cx="3545738" cy="1645920"/>
+          </a:xfrm>
+          <a:prstGeom prst="roundRect">
+            <a:avLst>
+              <a:gd name="adj" fmla="val 4444"/>
+            </a:avLst>
+          </a:prstGeom>
+          <a:solidFill>
+            <a:srgbClr val="F4F6F7"/>
+          </a:solidFill>
+          <a:ln/>
+        </p:spPr>
+      </p:sp>
+      <p:sp>
+        <p:nvSpPr>
+          <p:cNvPr id="54" name="Text 52"/>
+          <p:cNvSpPr txBox="1"/>
+          <p:nvPr/>
+        </p:nvSpPr>
+        <p:spPr>
+          <a:xfrm>
+            <a:off x="8280197" y="2029968"/>
+            <a:ext cx="3179978" cy="790042"/>
+          </a:xfrm>
+          <a:prstGeom prst="rect">
+            <a:avLst/>
+          </a:prstGeom>
+          <a:noFill/>
+          <a:ln/>
+        </p:spPr>
+        <p:txBody>
+          <a:bodyPr wrap="square" lIns="0" tIns="0" rIns="0" bIns="0" rtlCol="0" anchor="b">
+            <a:normAutofit/>
+          </a:bodyPr>
+          <a:lstStyle/>
+          <a:p>
+            <a:pPr indent="0" marL="0">
+              <a:buNone/>
+            </a:pPr>
+            <a:r>
+              <a:rPr lang="en-US" sz="2800" b="1" dirty="0">
+                <a:solidFill>
+                  <a:srgbClr val="1E6B52"/>
+                </a:solidFill>
+                <a:latin typeface="Cambria" pitchFamily="34" charset="0"/>
+                <a:ea typeface="Cambria" pitchFamily="34" charset="-122"/>
+                <a:cs typeface="Cambria" pitchFamily="34" charset="-120"/>
+              </a:rPr>
+              <a:t>50.4%</a:t>
+            </a:r>
+            <a:endParaRPr lang="en-US" sz="2800" dirty="0"/>
+          </a:p>
+        </p:txBody>
+      </p:sp>
+      <p:sp>
+        <p:nvSpPr>
+          <p:cNvPr id="55" name="Text 53"/>
+          <p:cNvSpPr txBox="1"/>
+          <p:nvPr/>
+        </p:nvSpPr>
+        <p:spPr>
+          <a:xfrm>
+            <a:off x="8280197" y="2838298"/>
+            <a:ext cx="3179978" cy="636422"/>
+          </a:xfrm>
+          <a:prstGeom prst="rect">
+            <a:avLst/>
+          </a:prstGeom>
+          <a:noFill/>
+          <a:ln/>
+        </p:spPr>
+        <p:txBody>
+          <a:bodyPr wrap="square" lIns="0" tIns="0" rIns="0" bIns="0" rtlCol="0" anchor="t">
+            <a:normAutofit/>
+          </a:bodyPr>
+          <a:lstStyle/>
+          <a:p>
+            <a:pPr indent="0" marL="0">
+              <a:buNone/>
+            </a:pPr>
+            <a:r>
+              <a:rPr lang="en-US" sz="1200" dirty="0">
+                <a:solidFill>
+                  <a:srgbClr val="4D5B69"/>
+                </a:solidFill>
+                <a:latin typeface="Calibri" pitchFamily="34" charset="0"/>
+                <a:ea typeface="Calibri" pitchFamily="34" charset="-122"/>
+                <a:cs typeface="Calibri" pitchFamily="34" charset="-120"/>
+              </a:rPr>
+              <a:t>women's share of the final roll</a:t>
+            </a:r>
+            <a:endParaRPr lang="en-US" sz="1200" dirty="0"/>
+          </a:p>
+        </p:txBody>
+      </p:sp>
+      <p:sp>
+        <p:nvSpPr>
+          <p:cNvPr id="56" name="Text 54"/>
           <p:cNvSpPr txBox="1"/>
           <p:nvPr/>
         </p:nvSpPr>
@@ -19009,7 +19113,7 @@
                 <a:ea typeface="Calibri" pitchFamily="34" charset="-122"/>
                 <a:cs typeface="Calibri" pitchFamily="34" charset="-120"/>
               </a:rPr>
-              <a:t>The names left off are not split by sex. These two figures cannot show whether women were left off more often than men.</a:t>
+              <a:t>The names left off are not split by sex. These figures cannot show whether women were left off more often than men.</a:t>
             </a:r>
             <a:endParaRPr lang="en-US" sz="1600" dirty="0"/>
           </a:p>
@@ -20134,7 +20238,7 @@
                 <a:ea typeface="Calibri" pitchFamily="34" charset="-122"/>
                 <a:cs typeface="Calibri" pitchFamily="34" charset="-120"/>
               </a:rPr>
-              <a:t>The final roll is due on 27 October 2026 and may change this.</a:t>
+              <a:t>By the final roll of 27 October the state's roll was 8,64,036 above the draft. No district figures were given for it.</a:t>
             </a:r>
             <a:endParaRPr lang="en-US" sz="1400" dirty="0"/>
           </a:p>

</xml_diff>